<commit_message>
Aplica S06 (diagrama de contexto DFD) y Sesion 14 (categorias de arquitectura)
- Figura 5 redibujada al estilo DFD clasico: proceso unico central,
  entidades externas y flujos de datos etiquetados (S06)
- Seccion 3.2 con terminologia de S06 (proceso unico, entidades
  externas, flujos de datos)
- Se anade la categoria de arquitectura de negocio (Estrada Hernandez)
  como base de las 4 categorias de la Sesion 14
- Material nuevo: S06_s1 y PPT Sesion 14
</commit_message>
<xml_diff>
--- a/Avance1/Avance1_Fogon_Andino.pptx
+++ b/Avance1/Avance1_Fogon_Andino.pptx
@@ -1216,7 +1216,7 @@
           <a:lstStyle/>
           <a:p>
             <a:r>
-              <a:t>Sistema central con 6 tipos de usuario y 2 sistemas externos: pasarela de pago y proveedores.</a:t>
+              <a:t>Sistema representado como un único proceso, rodeado de entidades externas (cliente, mozo, chef, cajero, repartidor, administrador, pasarela de pago y proveedores) con sus flujos de datos.</a:t>
             </a:r>
           </a:p>
         </p:txBody>
@@ -4510,8 +4510,8 @@
         </p:blipFill>
         <p:spPr>
           <a:xfrm>
-            <a:off x="1827489" y="914400"/>
-            <a:ext cx="8536717" cy="5669280"/>
+            <a:off x="1920087" y="914400"/>
+            <a:ext cx="8351520" cy="5669280"/>
           </a:xfrm>
           <a:prstGeom prst="rect">
             <a:avLst/>

</xml_diff>